<commit_message>
docs(pptx): sửa slide 2 (diagram trục vuông góc, không cắt hộp) + slide 15 (phóng ảnh nhịp mua, thêm panel hành vi)
Co-Authored-By: Claude Opus 4.8 (1M context) <noreply@anthropic.com>
</commit_message>
<xml_diff>
--- a/docs/OCH-CDP-Gioi-thieu.pptx
+++ b/docs/OCH-CDP-Gioi-thieu.pptx
@@ -11218,9 +11218,54 @@
           </a:p>
         </p:txBody>
       </p:sp>
+      <p:sp>
+        <p:nvSpPr>
+          <p:cNvPr id="19" name="TextBox 18"/>
+          <p:cNvSpPr txBox="1"/>
+          <p:nvPr/>
+        </p:nvSpPr>
+        <p:spPr>
+          <a:xfrm>
+            <a:off x="6263640" y="5980176"/>
+            <a:ext cx="5394959" cy="292608"/>
+          </a:xfrm>
+          <a:prstGeom prst="rect">
+            <a:avLst/>
+          </a:prstGeom>
+          <a:noFill/>
+        </p:spPr>
+        <p:txBody>
+          <a:bodyPr wrap="square" anchor="t" lIns="25400" rIns="25400" tIns="12700" bIns="12700">
+            <a:spAutoFit/>
+          </a:bodyPr>
+          <a:lstStyle/>
+          <a:p>
+            <a:pPr algn="ctr">
+              <a:lnSpc>
+                <a:spcPct val="100000"/>
+              </a:lnSpc>
+              <a:spcBef>
+                <a:spcPts val="0"/>
+              </a:spcBef>
+              <a:spcAft>
+                <a:spcPts val="400"/>
+              </a:spcAft>
+            </a:pPr>
+            <a:r>
+              <a:rPr sz="1250" b="0" i="1">
+                <a:solidFill>
+                  <a:srgbClr val="565564"/>
+                </a:solidFill>
+                <a:latin typeface="Calibri"/>
+              </a:rPr>
+              <a:t>Nhịp mua &amp; phân tích hành vi — chu kỳ, ngày quay lại dự kiến, churn risk.</a:t>
+            </a:r>
+          </a:p>
+        </p:txBody>
+      </p:sp>
       <p:pic>
         <p:nvPicPr>
-          <p:cNvPr id="18" name="Picture 17" descr="c360-cadence.png"/>
+          <p:cNvPr id="20" name="Picture 19" descr="image.png"/>
           <p:cNvPicPr>
             <a:picLocks noChangeAspect="1"/>
           </p:cNvPicPr>
@@ -11234,59 +11279,38 @@
         </p:blipFill>
         <p:spPr>
           <a:xfrm>
-            <a:off x="6309360" y="3465524"/>
-            <a:ext cx="5303520" cy="905358"/>
+            <a:off x="6309360" y="2361260"/>
+            <a:ext cx="5303520" cy="905037"/>
           </a:xfrm>
           <a:prstGeom prst="rect">
             <a:avLst/>
           </a:prstGeom>
         </p:spPr>
       </p:pic>
-      <p:sp>
-        <p:nvSpPr>
-          <p:cNvPr id="19" name="TextBox 18"/>
-          <p:cNvSpPr txBox="1"/>
-          <p:nvPr/>
-        </p:nvSpPr>
-        <p:spPr>
-          <a:xfrm>
-            <a:off x="6263640" y="5980176"/>
-            <a:ext cx="5394959" cy="292608"/>
-          </a:xfrm>
-          <a:prstGeom prst="rect">
-            <a:avLst/>
-          </a:prstGeom>
-          <a:noFill/>
-        </p:spPr>
-        <p:txBody>
-          <a:bodyPr wrap="square" anchor="t" lIns="25400" rIns="25400" tIns="12700" bIns="12700">
-            <a:spAutoFit/>
-          </a:bodyPr>
-          <a:lstStyle/>
-          <a:p>
-            <a:pPr algn="ctr">
-              <a:lnSpc>
-                <a:spcPct val="100000"/>
-              </a:lnSpc>
-              <a:spcBef>
-                <a:spcPts val="0"/>
-              </a:spcBef>
-              <a:spcAft>
-                <a:spcPts val="400"/>
-              </a:spcAft>
-            </a:pPr>
-            <a:r>
-              <a:rPr sz="1250" b="0" i="1">
-                <a:solidFill>
-                  <a:srgbClr val="565564"/>
-                </a:solidFill>
-                <a:latin typeface="Calibri"/>
-              </a:rPr>
-              <a:t>Nhịp mua — chu kỳ, ngày dự kiến quay lại, cảnh báo quá hạn.</a:t>
-            </a:r>
-          </a:p>
-        </p:txBody>
-      </p:sp>
+      <p:pic>
+        <p:nvPicPr>
+          <p:cNvPr id="21" name="Picture 20" descr="image.png"/>
+          <p:cNvPicPr>
+            <a:picLocks noChangeAspect="1"/>
+          </p:cNvPicPr>
+          <p:nvPr/>
+        </p:nvPicPr>
+        <p:blipFill>
+          <a:blip r:embed="rId3"/>
+          <a:stretch>
+            <a:fillRect/>
+          </a:stretch>
+        </p:blipFill>
+        <p:spPr>
+          <a:xfrm>
+            <a:off x="6309360" y="3403457"/>
+            <a:ext cx="5303520" cy="2071687"/>
+          </a:xfrm>
+          <a:prstGeom prst="rect">
+            <a:avLst/>
+          </a:prstGeom>
+        </p:spPr>
+      </p:pic>
     </p:spTree>
   </p:cSld>
   <p:clrMapOvr>
@@ -15233,75 +15257,75 @@
           </a:p>
         </p:txBody>
       </p:sp>
+      <p:sp>
+        <p:nvSpPr>
+          <p:cNvPr id="13" name="TextBox 12"/>
+          <p:cNvSpPr txBox="1"/>
+          <p:nvPr/>
+        </p:nvSpPr>
+        <p:spPr>
+          <a:xfrm>
+            <a:off x="6263640" y="5980176"/>
+            <a:ext cx="5394959" cy="292608"/>
+          </a:xfrm>
+          <a:prstGeom prst="rect">
+            <a:avLst/>
+          </a:prstGeom>
+          <a:noFill/>
+        </p:spPr>
+        <p:txBody>
+          <a:bodyPr wrap="square" anchor="t" lIns="25400" rIns="25400" tIns="12700" bIns="12700">
+            <a:spAutoFit/>
+          </a:bodyPr>
+          <a:lstStyle/>
+          <a:p>
+            <a:pPr algn="ctr">
+              <a:lnSpc>
+                <a:spcPct val="100000"/>
+              </a:lnSpc>
+              <a:spcBef>
+                <a:spcPts val="0"/>
+              </a:spcBef>
+              <a:spcAft>
+                <a:spcPts val="400"/>
+              </a:spcAft>
+            </a:pPr>
+            <a:r>
+              <a:rPr sz="1250" b="0" i="1">
+                <a:solidFill>
+                  <a:srgbClr val="565564"/>
+                </a:solidFill>
+                <a:latin typeface="Calibri"/>
+              </a:rPr>
+              <a:t>Sáu bản ghi rời — không bản nào biết các bản còn lại tồn tại.</a:t>
+            </a:r>
+          </a:p>
+        </p:txBody>
+      </p:sp>
       <p:pic>
         <p:nvPicPr>
-          <p:cNvPr id="12" name="Picture 11" descr="fragment.png"/>
+          <p:cNvPr id="14" name="Picture 13" descr="fragment.png"/>
           <p:cNvPicPr>
             <a:picLocks noChangeAspect="1"/>
           </p:cNvPicPr>
           <p:nvPr/>
         </p:nvPicPr>
         <p:blipFill>
-          <a:blip r:embed="rId2"/>
+          <a:blip r:embed="rId3"/>
           <a:stretch>
             <a:fillRect/>
           </a:stretch>
         </p:blipFill>
         <p:spPr>
           <a:xfrm>
-            <a:off x="6391753" y="1938528"/>
-            <a:ext cx="5138733" cy="3959352"/>
+            <a:off x="6445281" y="1938528"/>
+            <a:ext cx="5031676" cy="3959352"/>
           </a:xfrm>
           <a:prstGeom prst="rect">
             <a:avLst/>
           </a:prstGeom>
         </p:spPr>
       </p:pic>
-      <p:sp>
-        <p:nvSpPr>
-          <p:cNvPr id="13" name="TextBox 12"/>
-          <p:cNvSpPr txBox="1"/>
-          <p:nvPr/>
-        </p:nvSpPr>
-        <p:spPr>
-          <a:xfrm>
-            <a:off x="6263640" y="5980176"/>
-            <a:ext cx="5394959" cy="292608"/>
-          </a:xfrm>
-          <a:prstGeom prst="rect">
-            <a:avLst/>
-          </a:prstGeom>
-          <a:noFill/>
-        </p:spPr>
-        <p:txBody>
-          <a:bodyPr wrap="square" anchor="t" lIns="25400" rIns="25400" tIns="12700" bIns="12700">
-            <a:spAutoFit/>
-          </a:bodyPr>
-          <a:lstStyle/>
-          <a:p>
-            <a:pPr algn="ctr">
-              <a:lnSpc>
-                <a:spcPct val="100000"/>
-              </a:lnSpc>
-              <a:spcBef>
-                <a:spcPts val="0"/>
-              </a:spcBef>
-              <a:spcAft>
-                <a:spcPts val="400"/>
-              </a:spcAft>
-            </a:pPr>
-            <a:r>
-              <a:rPr sz="1250" b="0" i="1">
-                <a:solidFill>
-                  <a:srgbClr val="565564"/>
-                </a:solidFill>
-                <a:latin typeface="Calibri"/>
-              </a:rPr>
-              <a:t>Sáu bản ghi rời — không bản nào biết các bản còn lại tồn tại.</a:t>
-            </a:r>
-          </a:p>
-        </p:txBody>
-      </p:sp>
     </p:spTree>
   </p:cSld>
   <p:clrMapOvr>

</xml_diff>

<commit_message>
docs(pptx): sửa tiêu đề slide kết luận — nêu thẳng cam kết thay vì meta-khẩu hiệu
Co-Authored-By: Claude Opus 4.8 (1M context) <noreply@anthropic.com>
</commit_message>
<xml_diff>
--- a/docs/OCH-CDP-Gioi-thieu.pptx
+++ b/docs/OCH-CDP-Gioi-thieu.pptx
@@ -28881,7 +28881,7 @@
                 </a:solidFill>
                 <a:latin typeface="Calibri"/>
               </a:rPr>
-              <a:t>KẾT LUẬN</a:t>
+              <a:t>KẾT LUẬN — NĂM CƠ CHẾ CÀI SẴN TRONG LÕI HỆ THỐNG</a:t>
             </a:r>
           </a:p>
         </p:txBody>
@@ -28926,7 +28926,7 @@
                 </a:solidFill>
                 <a:latin typeface="Georgia"/>
               </a:rPr>
-              <a:t>Năm cơ chế khiến hệ thống này đáng tin — không phải khẩu hiệu</a:t>
+              <a:t>Không trùng doanh thu, không thất thoát điểm, không gửi sai người</a:t>
             </a:r>
           </a:p>
         </p:txBody>

</xml_diff>